<commit_message>
Zaktualizuj niepromowanych i prezentację
</commit_message>
<xml_diff>
--- a/assets/prezentacja_dydaktyka_frekwencja/prezentacja-dydaktyka-frekwencja.pptx
+++ b/assets/prezentacja_dydaktyka_frekwencja/prezentacja-dydaktyka-frekwencja.pptx
@@ -18648,7 +18648,7 @@
         </p:nvSpPr>
         <p:spPr>
           <a:xfrm>
-            <a:off x="777240" y="1170432"/>
+            <a:off x="777240" y="1152144"/>
             <a:ext cx="10881360" cy="457200"/>
           </a:xfrm>
           <a:prstGeom prst="rect">
@@ -18669,7 +18669,7 @@
                   <a:srgbClr val="8A97A8"/>
                 </a:solidFill>
               </a:rPr>
-              <a:t>Udział rośnie trzeci rok z rzędu — klasyfikacja roczna, więcej niż 2 oceny niedostateczne (brak promocji).</a:t>
+              <a:t>Udział rośnie trzeci rok z rzędu — klasyfikacja roczna; porównanie na tej samej podstawie (bez klas programowo najwyższych).</a:t>
             </a:r>
           </a:p>
         </p:txBody>
@@ -18783,7 +18783,7 @@
                   <a:srgbClr val="D64B4B"/>
                 </a:solidFill>
               </a:rPr>
-              <a:t>2,7%</a:t>
+              <a:t>2,3%</a:t>
             </a:r>
           </a:p>
         </p:txBody>
@@ -18817,7 +18817,7 @@
                   <a:srgbClr val="1F2A3A"/>
                 </a:solidFill>
               </a:rPr>
-              <a:t>18 z 678 uczniów</a:t>
+              <a:t>14 z 620 uczniów</a:t>
             </a:r>
           </a:p>
         </p:txBody>
@@ -18931,7 +18931,7 @@
                   <a:srgbClr val="D64B4B"/>
                 </a:solidFill>
               </a:rPr>
-              <a:t>3,3%</a:t>
+              <a:t>4,1%</a:t>
             </a:r>
           </a:p>
         </p:txBody>
@@ -18965,7 +18965,7 @@
                   <a:srgbClr val="1F2A3A"/>
                 </a:solidFill>
               </a:rPr>
-              <a:t>25 z 757 uczniów</a:t>
+              <a:t>25 z 604 uczniów</a:t>
             </a:r>
           </a:p>
         </p:txBody>
@@ -19079,7 +19079,7 @@
                   <a:srgbClr val="D64B4B"/>
                 </a:solidFill>
               </a:rPr>
-              <a:t>4,0%</a:t>
+              <a:t>5,0%</a:t>
             </a:r>
           </a:p>
         </p:txBody>
@@ -19113,7 +19113,7 @@
                   <a:srgbClr val="1F2A3A"/>
                 </a:solidFill>
               </a:rPr>
-              <a:t>34 z 841 uczniów</a:t>
+              <a:t>34 z 679 uczniów</a:t>
             </a:r>
           </a:p>
         </p:txBody>
@@ -19147,7 +19147,7 @@
                   <a:srgbClr val="1F3A5F"/>
                 </a:solidFill>
               </a:rPr>
-              <a:t>Udział niepromowanych wg typu szkoły</a:t>
+              <a:t>Udział niepromowanych wg typu szkoły (bez klas kończących)</a:t>
             </a:r>
           </a:p>
         </p:txBody>
@@ -19274,12 +19274,12 @@
                     <a:p>
                       <a:pPr algn="l"/>
                       <a:r>
-                        <a:rPr sz="1150" b="1">
+                        <a:rPr sz="1050" b="1">
                           <a:solidFill>
                             <a:srgbClr val="1F3A5F"/>
                           </a:solidFill>
                         </a:rPr>
-                        <a:t>Technikum</a:t>
+                        <a:t>Technikum (kl. 1–4)</a:t>
                       </a:r>
                     </a:p>
                   </a:txBody>
@@ -19296,12 +19296,12 @@
                     <a:p>
                       <a:pPr algn="ctr"/>
                       <a:r>
-                        <a:rPr sz="1150">
+                        <a:rPr sz="1100">
                           <a:solidFill>
                             <a:srgbClr val="1F2A3A"/>
                           </a:solidFill>
                         </a:rPr>
-                        <a:t>9 z 224 · 4,0%</a:t>
+                        <a:t>9 z 223 · 4,0%</a:t>
                       </a:r>
                     </a:p>
                   </a:txBody>
@@ -19318,7 +19318,7 @@
                     <a:p>
                       <a:pPr algn="ctr"/>
                       <a:r>
-                        <a:rPr sz="1150">
+                        <a:rPr sz="1100">
                           <a:solidFill>
                             <a:srgbClr val="1F2A3A"/>
                           </a:solidFill>
@@ -19340,7 +19340,7 @@
                     <a:p>
                       <a:pPr algn="ctr"/>
                       <a:r>
-                        <a:rPr sz="1150">
+                        <a:rPr sz="1100">
                           <a:solidFill>
                             <a:srgbClr val="1F2A3A"/>
                           </a:solidFill>
@@ -19364,12 +19364,12 @@
                     <a:p>
                       <a:pPr algn="l"/>
                       <a:r>
-                        <a:rPr sz="1150" b="1">
+                        <a:rPr sz="1050" b="1">
                           <a:solidFill>
                             <a:srgbClr val="1F3A5F"/>
                           </a:solidFill>
                         </a:rPr>
-                        <a:t>Szkoła branżowa</a:t>
+                        <a:t>Szkoła branżowa (bez kl. końc.)</a:t>
                       </a:r>
                     </a:p>
                   </a:txBody>
@@ -19386,12 +19386,12 @@
                     <a:p>
                       <a:pPr algn="ctr"/>
                       <a:r>
-                        <a:rPr sz="1150">
+                        <a:rPr sz="1100">
                           <a:solidFill>
                             <a:srgbClr val="1F2A3A"/>
                           </a:solidFill>
                         </a:rPr>
-                        <a:t>9 z 454 · 2,0%</a:t>
+                        <a:t>5 z 397 · 1,3%</a:t>
                       </a:r>
                     </a:p>
                   </a:txBody>
@@ -19408,12 +19408,12 @@
                     <a:p>
                       <a:pPr algn="ctr"/>
                       <a:r>
-                        <a:rPr sz="1150">
+                        <a:rPr sz="1100">
                           <a:solidFill>
                             <a:srgbClr val="1F2A3A"/>
                           </a:solidFill>
                         </a:rPr>
-                        <a:t>10 z 526 · 1,9%</a:t>
+                        <a:t>10 z 373 · 2,7%</a:t>
                       </a:r>
                     </a:p>
                   </a:txBody>
@@ -19430,12 +19430,12 @@
                     <a:p>
                       <a:pPr algn="ctr"/>
                       <a:r>
-                        <a:rPr sz="1150">
+                        <a:rPr sz="1100">
                           <a:solidFill>
                             <a:srgbClr val="1F2A3A"/>
                           </a:solidFill>
                         </a:rPr>
-                        <a:t>18 z 589 · 3,1%</a:t>
+                        <a:t>18 z 427 · 4,2%</a:t>
                       </a:r>
                     </a:p>
                   </a:txBody>
@@ -19479,7 +19479,7 @@
                   <a:srgbClr val="1F3A5F"/>
                 </a:solidFill>
               </a:rPr>
-              <a:t>Udział niepromowanych rośnie: 2,7% → 3,3% → 4,0%. Najsilniej w technikum (ok. 6%), znacznie mniej w szkole branżowej.</a:t>
+              <a:t>Udział niepromowanych rośnie: 2,3% → 4,1% → 5,0%. Najsilniej w technikum (ok. 6%); w szkole branżowej przyspiesza (1,3% → 4,2%).</a:t>
             </a:r>
           </a:p>
         </p:txBody>
@@ -19493,7 +19493,7 @@
         <p:spPr>
           <a:xfrm>
             <a:off x="777240" y="5897880"/>
-            <a:ext cx="10927080" cy="777240"/>
+            <a:ext cx="11064240" cy="914400"/>
           </a:xfrm>
           <a:prstGeom prst="rect">
             <a:avLst/>
@@ -19513,7 +19513,7 @@
                   <a:srgbClr val="8A97A8"/>
                 </a:solidFill>
               </a:rPr>
-              <a:t>Źródło: dzienniki klasyfikacji rocznej (pełna historia 2023–2026). Pokrycie: 2025/26 — komplet (37 oddziałów); 2023/24 i 2024/25 nie obejmują kilku klas programowo najwyższych (kończących), wśród których niepromowalność jest ~zerowa — realny udział w tych latach może być nieco niższy, co dodatkowo wzmacnia trend wzrostowy.</a:t>
+              <a:t>Dla porównywalności ze wszystkich lat wyłączono klasy programowo najwyższe (kończące: 5. technikum, 3. BS I, 4. BS II) — ich dzienników brakuje we wcześniejszych latach, a niepromowalność w nich jest ~zerowa. Liczby obejmują wszystkich uczniów sklasyfikowanych w danym roku, także tych, którzy już odeszli. (Z klasami kończącymi udział wynosi 2,7% → 3,3% → 4,0%.)</a:t>
             </a:r>
           </a:p>
         </p:txBody>

</xml_diff>